<commit_message>
Add KCD Beijing Saturday event link to slides
</commit_message>
<xml_diff>
--- a/tasks/kcd-beijing-2026-huge-cluster/dist/Huge-Cluster-or-Multi-Clusters-KCD-Beijing-2026.pptx
+++ b/tasks/kcd-beijing-2026-huge-cluster/dist/Huge-Cluster-or-Multi-Clusters-KCD-Beijing-2026.pptx
@@ -2649,6 +2649,66 @@
           </a:p>
         </p:txBody>
       </p:sp>
+      <p:sp>
+        <p:nvSpPr>
+          <p:cNvPr id="21" name="Text 19"/>
+          <p:cNvSpPr/>
+          <p:nvPr/>
+        </p:nvSpPr>
+        <p:spPr>
+          <a:xfrm>
+            <a:off x="822960" y="5623560"/>
+            <a:ext cx="10607040" cy="201168"/>
+          </a:xfrm>
+          <a:prstGeom prst="rect">
+            <a:avLst/>
+          </a:prstGeom>
+          <a:noFill/>
+          <a:ln/>
+        </p:spPr>
+        <p:txBody>
+          <a:bodyPr wrap="square" lIns="0" tIns="0" rIns="0" bIns="0" rtlCol="0" anchor="ctr"/>
+          <a:lstStyle/>
+          <a:p>
+            <a:pPr indent="0" marL="0">
+              <a:buNone/>
+            </a:pPr>
+            <a:r>
+              <a:rPr lang="en-US" sz="880" b="1" dirty="0">
+                <a:solidFill>
+                  <a:srgbClr val="E8DDD2"/>
+                </a:solidFill>
+                <a:latin typeface="PingFang SC" pitchFamily="34" charset="0"/>
+                <a:ea typeface="PingFang SC" pitchFamily="34" charset="-122"/>
+                <a:cs typeface="PingFang SC" pitchFamily="34" charset="-120"/>
+              </a:rPr>
+              <a:t>本周六（2026-03-21）KCD Beijing 活动链接：</a:t>
+            </a:r>
+            <a:pPr indent="0" marL="0">
+              <a:buNone/>
+            </a:pPr>
+            <a:r>
+              <a:rPr lang="en-US" sz="880" u="sng" dirty="0">
+                <a:solidFill>
+                  <a:srgbClr val="E8C778"/>
+                </a:solidFill>
+                <a:latin typeface="PingFang SC" pitchFamily="34" charset="0"/>
+                <a:ea typeface="PingFang SC" pitchFamily="34" charset="-122"/>
+                <a:cs typeface="PingFang SC" pitchFamily="34" charset="-120"/>
+                <a:hlinkClick r:id="rId1" invalidUrl="" action="" tgtFrame="" tooltip="" history="1" highlightClick="0" endSnd="0">
+                  <a:extLst>
+                    <a:ext uri="{A12FA001-AC4F-418D-AE19-62706E023703}">
+                      <ahyp:hlinkClr xmlns:ahyp="http://schemas.microsoft.com/office/drawing/2018/hyperlinkcolor" val="tx"/>
+                    </a:ext>
+                  </a:extLst>
+                </a:hlinkClick>
+              </a:rPr>
+              <a:t>https://community.cncf.io/events/details/cncf-kcd-beijing-presents-kcd-beijing-vllm-2026/</a:t>
+            </a:r>
+            <a:endParaRPr lang="en-US" sz="880" dirty="0"/>
+          </a:p>
+        </p:txBody>
+      </p:sp>
     </p:spTree>
   </p:cSld>
   <p:clrMapOvr>
@@ -8609,6 +8669,66 @@
               <a:t>Huge Cluster or Multi-Clusters? Keep the bottleneck visible.</a:t>
             </a:r>
             <a:endParaRPr lang="en-US" sz="1000" dirty="0"/>
+          </a:p>
+        </p:txBody>
+      </p:sp>
+      <p:sp>
+        <p:nvSpPr>
+          <p:cNvPr id="25" name="Text 23"/>
+          <p:cNvSpPr/>
+          <p:nvPr/>
+        </p:nvSpPr>
+        <p:spPr>
+          <a:xfrm>
+            <a:off x="896112" y="5669280"/>
+            <a:ext cx="10424160" cy="201168"/>
+          </a:xfrm>
+          <a:prstGeom prst="rect">
+            <a:avLst/>
+          </a:prstGeom>
+          <a:noFill/>
+          <a:ln/>
+        </p:spPr>
+        <p:txBody>
+          <a:bodyPr wrap="square" lIns="0" tIns="0" rIns="0" bIns="0" rtlCol="0" anchor="ctr"/>
+          <a:lstStyle/>
+          <a:p>
+            <a:pPr indent="0" marL="0">
+              <a:buNone/>
+            </a:pPr>
+            <a:r>
+              <a:rPr lang="en-US" sz="910" b="1" dirty="0">
+                <a:solidFill>
+                  <a:srgbClr val="171717"/>
+                </a:solidFill>
+                <a:latin typeface="PingFang SC" pitchFamily="34" charset="0"/>
+                <a:ea typeface="PingFang SC" pitchFamily="34" charset="-122"/>
+                <a:cs typeface="PingFang SC" pitchFamily="34" charset="-120"/>
+              </a:rPr>
+              <a:t>KCD Beijing（2026-03-21, Sat）活动页：</a:t>
+            </a:r>
+            <a:pPr indent="0" marL="0">
+              <a:buNone/>
+            </a:pPr>
+            <a:r>
+              <a:rPr lang="en-US" sz="910" u="sng" dirty="0">
+                <a:solidFill>
+                  <a:srgbClr val="C63C30"/>
+                </a:solidFill>
+                <a:latin typeface="PingFang SC" pitchFamily="34" charset="0"/>
+                <a:ea typeface="PingFang SC" pitchFamily="34" charset="-122"/>
+                <a:cs typeface="PingFang SC" pitchFamily="34" charset="-120"/>
+                <a:hlinkClick r:id="rId1" invalidUrl="" action="" tgtFrame="" tooltip="" history="1" highlightClick="0" endSnd="0">
+                  <a:extLst>
+                    <a:ext uri="{A12FA001-AC4F-418D-AE19-62706E023703}">
+                      <ahyp:hlinkClr xmlns:ahyp="http://schemas.microsoft.com/office/drawing/2018/hyperlinkcolor" val="tx"/>
+                    </a:ext>
+                  </a:extLst>
+                </a:hlinkClick>
+              </a:rPr>
+              <a:t>https://community.cncf.io/events/details/cncf-kcd-beijing-presents-kcd-beijing-vllm-2026/</a:t>
+            </a:r>
+            <a:endParaRPr lang="en-US" sz="910" dirty="0"/>
           </a:p>
         </p:txBody>
       </p:sp>

</xml_diff>